<commit_message>
Q807 disconnected line addressed
</commit_message>
<xml_diff>
--- a/CKDSurveillance/PPT/Q807.pptx
+++ b/CKDSurveillance/PPT/Q807.pptx
@@ -1661,7 +1661,7 @@
             <c:numRef>
               <c:f>'Age Strata'!$M$71:$Q$71</c:f>
               <c:numCache>
-                <c:formatCode>0.0%</c:formatCode>
+                <c:formatCode>General</c:formatCode>
                 <c:ptCount val="5"/>
               </c:numCache>
             </c:numRef>
@@ -6950,7 +6950,7 @@
           <a:p>
             <a:fld id="{03F4A4C7-F2E1-4AC2-88AC-896135C15CAD}" type="datetimeFigureOut">
               <a:rPr lang="en-US" smtClean="0"/>
-              <a:t>1/15/2026</a:t>
+              <a:t>2/11/2026</a:t>
             </a:fld>
             <a:endParaRPr lang="en-US"/>
           </a:p>
@@ -7158,7 +7158,7 @@
           <a:p>
             <a:fld id="{03F4A4C7-F2E1-4AC2-88AC-896135C15CAD}" type="datetimeFigureOut">
               <a:rPr lang="en-US" smtClean="0"/>
-              <a:t>1/15/2026</a:t>
+              <a:t>2/11/2026</a:t>
             </a:fld>
             <a:endParaRPr lang="en-US"/>
           </a:p>
@@ -7367,7 +7367,7 @@
           <a:p>
             <a:fld id="{03F4A4C7-F2E1-4AC2-88AC-896135C15CAD}" type="datetimeFigureOut">
               <a:rPr lang="en-US" smtClean="0"/>
-              <a:t>1/15/2026</a:t>
+              <a:t>2/11/2026</a:t>
             </a:fld>
             <a:endParaRPr lang="en-US"/>
           </a:p>
@@ -7682,7 +7682,7 @@
           <a:p>
             <a:fld id="{03F4A4C7-F2E1-4AC2-88AC-896135C15CAD}" type="datetimeFigureOut">
               <a:rPr lang="en-US" smtClean="0"/>
-              <a:t>1/15/2026</a:t>
+              <a:t>2/11/2026</a:t>
             </a:fld>
             <a:endParaRPr lang="en-US"/>
           </a:p>
@@ -7988,7 +7988,7 @@
           <a:p>
             <a:fld id="{03F4A4C7-F2E1-4AC2-88AC-896135C15CAD}" type="datetimeFigureOut">
               <a:rPr lang="en-US" smtClean="0"/>
-              <a:t>1/15/2026</a:t>
+              <a:t>2/11/2026</a:t>
             </a:fld>
             <a:endParaRPr lang="en-US"/>
           </a:p>
@@ -8436,7 +8436,7 @@
           <a:p>
             <a:fld id="{03F4A4C7-F2E1-4AC2-88AC-896135C15CAD}" type="datetimeFigureOut">
               <a:rPr lang="en-US" smtClean="0"/>
-              <a:t>1/15/2026</a:t>
+              <a:t>2/11/2026</a:t>
             </a:fld>
             <a:endParaRPr lang="en-US"/>
           </a:p>
@@ -8618,7 +8618,7 @@
           <a:p>
             <a:fld id="{03F4A4C7-F2E1-4AC2-88AC-896135C15CAD}" type="datetimeFigureOut">
               <a:rPr lang="en-US" smtClean="0"/>
-              <a:t>1/15/2026</a:t>
+              <a:t>2/11/2026</a:t>
             </a:fld>
             <a:endParaRPr lang="en-US"/>
           </a:p>
@@ -8767,7 +8767,7 @@
           <a:p>
             <a:fld id="{03F4A4C7-F2E1-4AC2-88AC-896135C15CAD}" type="datetimeFigureOut">
               <a:rPr lang="en-US" smtClean="0"/>
-              <a:t>1/15/2026</a:t>
+              <a:t>2/11/2026</a:t>
             </a:fld>
             <a:endParaRPr lang="en-US"/>
           </a:p>
@@ -9115,7 +9115,7 @@
           <a:p>
             <a:fld id="{03F4A4C7-F2E1-4AC2-88AC-896135C15CAD}" type="datetimeFigureOut">
               <a:rPr lang="en-US" smtClean="0"/>
-              <a:t>1/15/2026</a:t>
+              <a:t>2/11/2026</a:t>
             </a:fld>
             <a:endParaRPr lang="en-US"/>
           </a:p>
@@ -9443,7 +9443,7 @@
           <a:p>
             <a:fld id="{03F4A4C7-F2E1-4AC2-88AC-896135C15CAD}" type="datetimeFigureOut">
               <a:rPr lang="en-US" smtClean="0"/>
-              <a:t>1/15/2026</a:t>
+              <a:t>2/11/2026</a:t>
             </a:fld>
             <a:endParaRPr lang="en-US"/>
           </a:p>
@@ -9721,7 +9721,7 @@
           <a:p>
             <a:fld id="{03F4A4C7-F2E1-4AC2-88AC-896135C15CAD}" type="datetimeFigureOut">
               <a:rPr lang="en-US" smtClean="0"/>
-              <a:t>1/15/2026</a:t>
+              <a:t>2/11/2026</a:t>
             </a:fld>
             <a:endParaRPr lang="en-US"/>
           </a:p>
@@ -10612,7 +10612,7 @@
           <a:p>
             <a:r>
               <a:rPr lang="en-US" sz="1200" dirty="0"/>
-              <a:t>Note: Estimates for Age Category "18-39 years" were suppressed due to a large standard error stemming from a small sample size.</a:t>
+              <a:t>Note: Estimates for Age Category “20-39 years" were suppressed due to a large standard error stemming from a small sample size.</a:t>
             </a:r>
           </a:p>
         </p:txBody>

</xml_diff>